<commit_message>
Update presentation for post-merge fixes and accurate counts
- Bug count was stale at 4; now reflects all 7 fixes (adds the Go
  raw-string corruption fix and the two TypeScript/JavaScript
  contextual-keyword fixes)
- Updates slide 1 headline/stats, slide 2 agenda, slide 3/6/8 summary
  bullets, and condenses slide 12's 4-card layout into one 7-item list
- Corrects the test-line count (+2,600 -> +4,500) and slide 4's stale
  "current HEAD" label
- Verified via content extraction, file validation, and a full visual
  render of every changed slide
</commit_message>
<xml_diff>
--- a/docs/simian-4.2.2-presentation.pptx
+++ b/docs/simian-4.2.2-presentation.pptx
@@ -3514,7 +3514,7 @@
                 </a:solidFill>
                 <a:latin typeface="Georgia"/>
               </a:rPr>
-              <a:t>Four Quiet Bugs, Fixed.</a:t>
+              <a:t>Seven Quiet Bugs, Fixed.</a:t>
             </a:r>
           </a:p>
         </p:txBody>
@@ -3559,7 +3559,7 @@
                 </a:solidFill>
                 <a:latin typeface="Calibri"/>
               </a:rPr>
-              <a:t>Go, TypeScript &amp; Python parser support, plus four duplicate-detection bug fixes</a:t>
+              <a:t>Go, TypeScript &amp; Python parser support, plus seven duplicate-detection bug fixes</a:t>
             </a:r>
           </a:p>
         </p:txBody>
@@ -3614,7 +3614,7 @@
                 </a:solidFill>
                 <a:latin typeface="Calibri"/>
               </a:rPr>
-              <a:t>+2,600 test lines</a:t>
+              <a:t>+4,500 test lines</a:t>
             </a:r>
           </a:p>
         </p:txBody>
@@ -3724,7 +3724,7 @@
                 </a:solidFill>
                 <a:latin typeface="Calibri"/>
               </a:rPr>
-              <a:t>4 bug fixes</a:t>
+              <a:t>7 bug fixes</a:t>
             </a:r>
           </a:p>
         </p:txBody>
@@ -4968,111 +4968,21 @@
                 </a:solidFill>
                 <a:latin typeface="Georgia"/>
               </a:rPr>
-              <a:t>Four classification bugs, closed</a:t>
-            </a:r>
-          </a:p>
-        </p:txBody>
-      </p:sp>
-      <p:sp>
-        <p:nvSpPr>
-          <p:cNvPr id="5" name="Rectangle 4"/>
-          <p:cNvSpPr/>
-          <p:nvPr/>
-        </p:nvSpPr>
-        <p:spPr>
-          <a:xfrm>
-            <a:off x="640080" y="1170432"/>
-            <a:ext cx="502920" cy="38100"/>
-          </a:xfrm>
-          <a:prstGeom prst="rect">
-            <a:avLst/>
-          </a:prstGeom>
-          <a:solidFill>
-            <a:srgbClr val="C9591F"/>
-          </a:solidFill>
-          <a:ln>
-            <a:noFill/>
-          </a:ln>
-          <a:effectLst/>
-        </p:spPr>
-        <p:style>
-          <a:lnRef idx="1">
-            <a:schemeClr val="accent1"/>
-          </a:lnRef>
-          <a:fillRef idx="3">
-            <a:schemeClr val="accent1"/>
-          </a:fillRef>
-          <a:effectRef idx="2">
-            <a:schemeClr val="accent1"/>
-          </a:effectRef>
-          <a:fontRef idx="minor">
-            <a:schemeClr val="lt1"/>
-          </a:fontRef>
-        </p:style>
-        <p:txBody>
-          <a:bodyPr rtlCol="0" anchor="ctr"/>
-          <a:lstStyle/>
-          <a:p>
-            <a:pPr algn="ctr"/>
-          </a:p>
-        </p:txBody>
-      </p:sp>
-      <p:sp>
-        <p:nvSpPr>
-          <p:cNvPr id="6" name="Rectangle 5"/>
-          <p:cNvSpPr/>
-          <p:nvPr/>
-        </p:nvSpPr>
-        <p:spPr>
-          <a:xfrm>
-            <a:off x="640080" y="1508760"/>
-            <a:ext cx="5257800" cy="2331720"/>
-          </a:xfrm>
-          <a:prstGeom prst="rect">
-            <a:avLst/>
-          </a:prstGeom>
-          <a:solidFill>
-            <a:srgbClr val="F7F6F2"/>
-          </a:solidFill>
-          <a:ln w="9525">
-            <a:solidFill>
-              <a:srgbClr val="E1E0D9"/>
-            </a:solidFill>
-          </a:ln>
-          <a:effectLst/>
-        </p:spPr>
-        <p:style>
-          <a:lnRef idx="1">
-            <a:schemeClr val="accent1"/>
-          </a:lnRef>
-          <a:fillRef idx="3">
-            <a:schemeClr val="accent1"/>
-          </a:fillRef>
-          <a:effectRef idx="2">
-            <a:schemeClr val="accent1"/>
-          </a:effectRef>
-          <a:fontRef idx="minor">
-            <a:schemeClr val="lt1"/>
-          </a:fontRef>
-        </p:style>
-        <p:txBody>
-          <a:bodyPr rtlCol="0" anchor="ctr"/>
-          <a:lstStyle/>
-          <a:p>
-            <a:pPr algn="ctr"/>
-          </a:p>
-        </p:txBody>
-      </p:sp>
-      <p:sp>
-        <p:nvSpPr>
-          <p:cNvPr id="7" name="TextBox 6"/>
+              <a:t>Seven classification bugs, closed</a:t>
+            </a:r>
+          </a:p>
+        </p:txBody>
+      </p:sp>
+      <p:sp>
+        <p:nvSpPr>
+          <p:cNvPr id="100" name="TextBox Bugs"/>
           <p:cNvSpPr txBox="1"/>
           <p:nvPr/>
         </p:nvSpPr>
         <p:spPr>
           <a:xfrm>
-            <a:off x="822960" y="1618488"/>
-            <a:ext cx="4892040" cy="822960"/>
+            <a:off x="640080" y="1477008"/>
+            <a:ext cx="10881360" cy="4800600"/>
           </a:xfrm>
           <a:prstGeom prst="rect">
             <a:avLst/>
@@ -5085,646 +4995,136 @@
           </a:bodyPr>
           <a:lstStyle/>
           <a:p>
-            <a:r>
-              <a:rPr sz="1500" b="1">
+            <a:pPr>
+              <a:lnSpc>
+                <a:spcPct val="115000"/>
+              </a:lnSpc>
+              <a:spcAft>
+                <a:spcPts val="1800"/>
+              </a:spcAft>
+            </a:pPr>
+            <a:r>
+              <a:rPr sz="1850" b="1">
                 <a:solidFill>
                   <a:srgbClr val="1A1A18"/>
                 </a:solidFill>
                 <a:latin typeface="Calibri"/>
               </a:rPr>
-              <a:t>1.  Single-letter generics misclassified</a:t>
-            </a:r>
-          </a:p>
-          <a:p>
-            <a:r>
-              <a:rPr sz="1150" i="1">
-                <a:solidFill>
-                  <a:srgbClr val="52514E"/>
-                </a:solidFill>
-                <a:latin typeface="Calibri"/>
-              </a:rPr>
-              <a:t>T, K, V were classed CONSTANT, not TYPE</a:t>
-            </a:r>
-          </a:p>
-        </p:txBody>
-      </p:sp>
-      <p:sp>
-        <p:nvSpPr>
-          <p:cNvPr id="8" name="Rectangle 7"/>
-          <p:cNvSpPr/>
-          <p:nvPr/>
-        </p:nvSpPr>
-        <p:spPr>
-          <a:xfrm>
-            <a:off x="822960" y="2468880"/>
-            <a:ext cx="4892040" cy="1234440"/>
-          </a:xfrm>
-          <a:prstGeom prst="rect">
-            <a:avLst/>
-          </a:prstGeom>
-          <a:solidFill>
-            <a:srgbClr val="222220"/>
-          </a:solidFill>
-          <a:ln w="9525">
-            <a:solidFill>
-              <a:srgbClr val="E1E0D9"/>
-            </a:solidFill>
-          </a:ln>
-          <a:effectLst/>
-        </p:spPr>
-        <p:style>
-          <a:lnRef idx="1">
-            <a:schemeClr val="accent1"/>
-          </a:lnRef>
-          <a:fillRef idx="3">
-            <a:schemeClr val="accent1"/>
-          </a:fillRef>
-          <a:effectRef idx="2">
-            <a:schemeClr val="accent1"/>
-          </a:effectRef>
-          <a:fontRef idx="minor">
-            <a:schemeClr val="lt1"/>
-          </a:fontRef>
-        </p:style>
-        <p:txBody>
-          <a:bodyPr rtlCol="0" anchor="ctr" wrap="square" lIns="164592" rIns="164592" tIns="128016" bIns="128016"/>
-          <a:lstStyle/>
-          <a:p>
-            <a:pPr algn="ctr">
-              <a:lnSpc>
-                <a:spcPct val="125000"/>
-              </a:lnSpc>
-            </a:pPr>
-            <a:r>
-              <a:rPr sz="1150">
-                <a:solidFill>
-                  <a:srgbClr val="898781"/>
-                </a:solidFill>
-                <a:latin typeface="Consolas"/>
-              </a:rPr>
-              <a:t>RecogniseIdentifiersTokenVisitor.java</a:t>
+              <a:t>1. Single-letter generics (T, K, V) were classed CONSTANT instead of TYPE</a:t>
             </a:r>
           </a:p>
           <a:p>
             <a:pPr>
               <a:lnSpc>
-                <a:spcPct val="125000"/>
-              </a:lnSpc>
-            </a:pPr>
-            <a:r>
-              <a:rPr sz="1150">
-                <a:solidFill>
-                  <a:srgbClr val="B6342F"/>
-                </a:solidFill>
-                <a:latin typeface="Consolas"/>
-              </a:rPr>
-              <a:t>- return true;  // any all-caps name is a constant</a:t>
+                <a:spcPct val="115000"/>
+              </a:lnSpc>
+              <a:spcAft>
+                <a:spcPts val="1800"/>
+              </a:spcAft>
+            </a:pPr>
+            <a:r>
+              <a:rPr sz="1850" b="1">
+                <a:solidFill>
+                  <a:srgbClr val="1A1A18"/>
+                </a:solidFill>
+                <a:latin typeface="Calibri"/>
+              </a:rPr>
+              <a:t>2. Underscore-only names ('_') were classed CONSTANT instead of VARIABLE</a:t>
             </a:r>
           </a:p>
           <a:p>
             <a:pPr>
               <a:lnSpc>
-                <a:spcPct val="125000"/>
-              </a:lnSpc>
-            </a:pPr>
-            <a:r>
-              <a:rPr sz="1150">
-                <a:solidFill>
-                  <a:srgbClr val="006300"/>
-                </a:solidFill>
-                <a:latin typeface="Consolas"/>
-              </a:rPr>
-              <a:t>+ if (name.length() == 1) return false;  // fall through to isTypeName</a:t>
-            </a:r>
-          </a:p>
-        </p:txBody>
-      </p:sp>
-      <p:sp>
-        <p:nvSpPr>
-          <p:cNvPr id="9" name="Rectangle 8"/>
-          <p:cNvSpPr/>
-          <p:nvPr/>
-        </p:nvSpPr>
-        <p:spPr>
-          <a:xfrm>
-            <a:off x="6355080" y="1508760"/>
-            <a:ext cx="5257800" cy="2331720"/>
-          </a:xfrm>
-          <a:prstGeom prst="rect">
-            <a:avLst/>
-          </a:prstGeom>
-          <a:solidFill>
-            <a:srgbClr val="F7F6F2"/>
-          </a:solidFill>
-          <a:ln w="9525">
-            <a:solidFill>
-              <a:srgbClr val="E1E0D9"/>
-            </a:solidFill>
-          </a:ln>
-          <a:effectLst/>
-        </p:spPr>
-        <p:style>
-          <a:lnRef idx="1">
-            <a:schemeClr val="accent1"/>
-          </a:lnRef>
-          <a:fillRef idx="3">
-            <a:schemeClr val="accent1"/>
-          </a:fillRef>
-          <a:effectRef idx="2">
-            <a:schemeClr val="accent1"/>
-          </a:effectRef>
-          <a:fontRef idx="minor">
-            <a:schemeClr val="lt1"/>
-          </a:fontRef>
-        </p:style>
-        <p:txBody>
-          <a:bodyPr rtlCol="0" anchor="ctr"/>
-          <a:lstStyle/>
-          <a:p>
-            <a:pPr algn="ctr"/>
-          </a:p>
-        </p:txBody>
-      </p:sp>
-      <p:sp>
-        <p:nvSpPr>
-          <p:cNvPr id="10" name="TextBox 9"/>
-          <p:cNvSpPr txBox="1"/>
-          <p:nvPr/>
-        </p:nvSpPr>
-        <p:spPr>
-          <a:xfrm>
-            <a:off x="6537960" y="1618488"/>
-            <a:ext cx="4892040" cy="822960"/>
-          </a:xfrm>
-          <a:prstGeom prst="rect">
-            <a:avLst/>
-          </a:prstGeom>
-          <a:noFill/>
-        </p:spPr>
-        <p:txBody>
-          <a:bodyPr wrap="square">
-            <a:spAutoFit/>
-          </a:bodyPr>
-          <a:lstStyle/>
-          <a:p>
-            <a:r>
-              <a:rPr sz="1500" b="1">
+                <a:spcPct val="115000"/>
+              </a:lnSpc>
+              <a:spcAft>
+                <a:spcPts val="1800"/>
+              </a:spcAft>
+            </a:pPr>
+            <a:r>
+              <a:rPr sz="1850" b="1">
                 <a:solidFill>
                   <a:srgbClr val="1A1A18"/>
                 </a:solidFill>
                 <a:latin typeface="Calibri"/>
               </a:rPr>
-              <a:t>2.  Underscore-only names misclassified</a:t>
-            </a:r>
-          </a:p>
-          <a:p>
-            <a:r>
-              <a:rPr sz="1150" i="1">
-                <a:solidFill>
-                  <a:srgbClr val="52514E"/>
-                </a:solidFill>
-                <a:latin typeface="Calibri"/>
-              </a:rPr>
-              <a:t>'_' was classed CONSTANT, not VARIABLE</a:t>
-            </a:r>
-          </a:p>
-        </p:txBody>
-      </p:sp>
-      <p:sp>
-        <p:nvSpPr>
-          <p:cNvPr id="11" name="Rectangle 10"/>
-          <p:cNvSpPr/>
-          <p:nvPr/>
-        </p:nvSpPr>
-        <p:spPr>
-          <a:xfrm>
-            <a:off x="6537960" y="2468880"/>
-            <a:ext cx="4892040" cy="1234440"/>
-          </a:xfrm>
-          <a:prstGeom prst="rect">
-            <a:avLst/>
-          </a:prstGeom>
-          <a:solidFill>
-            <a:srgbClr val="222220"/>
-          </a:solidFill>
-          <a:ln w="9525">
-            <a:solidFill>
-              <a:srgbClr val="E1E0D9"/>
-            </a:solidFill>
-          </a:ln>
-          <a:effectLst/>
-        </p:spPr>
-        <p:style>
-          <a:lnRef idx="1">
-            <a:schemeClr val="accent1"/>
-          </a:lnRef>
-          <a:fillRef idx="3">
-            <a:schemeClr val="accent1"/>
-          </a:fillRef>
-          <a:effectRef idx="2">
-            <a:schemeClr val="accent1"/>
-          </a:effectRef>
-          <a:fontRef idx="minor">
-            <a:schemeClr val="lt1"/>
-          </a:fontRef>
-        </p:style>
-        <p:txBody>
-          <a:bodyPr rtlCol="0" anchor="ctr" wrap="square" lIns="164592" rIns="164592" tIns="128016" bIns="128016"/>
-          <a:lstStyle/>
-          <a:p>
-            <a:pPr algn="ctr">
-              <a:lnSpc>
-                <a:spcPct val="125000"/>
-              </a:lnSpc>
-            </a:pPr>
-            <a:r>
-              <a:rPr sz="1150">
-                <a:solidFill>
-                  <a:srgbClr val="898781"/>
-                </a:solidFill>
-                <a:latin typeface="Consolas"/>
-              </a:rPr>
-              <a:t>RecogniseIdentifiersTokenVisitor.java</a:t>
+              <a:t>3. Python '//' floor-division was read as a line comment, deleting the rest of the line</a:t>
             </a:r>
           </a:p>
           <a:p>
             <a:pPr>
               <a:lnSpc>
-                <a:spcPct val="125000"/>
-              </a:lnSpc>
-            </a:pPr>
-            <a:r>
-              <a:rPr sz="1150">
-                <a:solidFill>
-                  <a:srgbClr val="006300"/>
-                </a:solidFill>
-                <a:latin typeface="Consolas"/>
-              </a:rPr>
-              <a:t>+ return hasUpperCase;  // '_' has no uppercase letter → VARIABLE</a:t>
-            </a:r>
-          </a:p>
-        </p:txBody>
-      </p:sp>
-      <p:sp>
-        <p:nvSpPr>
-          <p:cNvPr id="12" name="Rectangle 11"/>
-          <p:cNvSpPr/>
-          <p:nvPr/>
-        </p:nvSpPr>
-        <p:spPr>
-          <a:xfrm>
-            <a:off x="640080" y="3977639"/>
-            <a:ext cx="5257800" cy="2331720"/>
-          </a:xfrm>
-          <a:prstGeom prst="rect">
-            <a:avLst/>
-          </a:prstGeom>
-          <a:solidFill>
-            <a:srgbClr val="F7F6F2"/>
-          </a:solidFill>
-          <a:ln w="9525">
-            <a:solidFill>
-              <a:srgbClr val="E1E0D9"/>
-            </a:solidFill>
-          </a:ln>
-          <a:effectLst/>
-        </p:spPr>
-        <p:style>
-          <a:lnRef idx="1">
-            <a:schemeClr val="accent1"/>
-          </a:lnRef>
-          <a:fillRef idx="3">
-            <a:schemeClr val="accent1"/>
-          </a:fillRef>
-          <a:effectRef idx="2">
-            <a:schemeClr val="accent1"/>
-          </a:effectRef>
-          <a:fontRef idx="minor">
-            <a:schemeClr val="lt1"/>
-          </a:fontRef>
-        </p:style>
-        <p:txBody>
-          <a:bodyPr rtlCol="0" anchor="ctr"/>
-          <a:lstStyle/>
-          <a:p>
-            <a:pPr algn="ctr"/>
-          </a:p>
-        </p:txBody>
-      </p:sp>
-      <p:sp>
-        <p:nvSpPr>
-          <p:cNvPr id="13" name="TextBox 12"/>
-          <p:cNvSpPr txBox="1"/>
-          <p:nvPr/>
-        </p:nvSpPr>
-        <p:spPr>
-          <a:xfrm>
-            <a:off x="822960" y="4087367"/>
-            <a:ext cx="4892040" cy="822960"/>
-          </a:xfrm>
-          <a:prstGeom prst="rect">
-            <a:avLst/>
-          </a:prstGeom>
-          <a:noFill/>
-        </p:spPr>
-        <p:txBody>
-          <a:bodyPr wrap="square">
-            <a:spAutoFit/>
-          </a:bodyPr>
-          <a:lstStyle/>
-          <a:p>
-            <a:r>
-              <a:rPr sz="1500" b="1">
+                <a:spcPct val="115000"/>
+              </a:lnSpc>
+              <a:spcAft>
+                <a:spcPts val="1800"/>
+              </a:spcAft>
+            </a:pPr>
+            <a:r>
+              <a:rPr sz="1850" b="1">
                 <a:solidFill>
                   <a:srgbClr val="1A1A18"/>
                 </a:solidFill>
                 <a:latin typeface="Calibri"/>
               </a:rPr>
-              <a:t>3.  Python // read as a comment</a:t>
-            </a:r>
-          </a:p>
-          <a:p>
-            <a:r>
-              <a:rPr sz="1150" i="1">
-                <a:solidFill>
-                  <a:srgbClr val="52514E"/>
-                </a:solidFill>
-                <a:latin typeface="Calibri"/>
-              </a:rPr>
-              <a:t>Floor-division silently deleted the rest of the line</a:t>
-            </a:r>
-          </a:p>
-        </p:txBody>
-      </p:sp>
-      <p:sp>
-        <p:nvSpPr>
-          <p:cNvPr id="14" name="Rectangle 13"/>
-          <p:cNvSpPr/>
-          <p:nvPr/>
-        </p:nvSpPr>
-        <p:spPr>
-          <a:xfrm>
-            <a:off x="822960" y="4937759"/>
-            <a:ext cx="4892040" cy="1234440"/>
-          </a:xfrm>
-          <a:prstGeom prst="rect">
-            <a:avLst/>
-          </a:prstGeom>
-          <a:solidFill>
-            <a:srgbClr val="222220"/>
-          </a:solidFill>
-          <a:ln w="9525">
-            <a:solidFill>
-              <a:srgbClr val="E1E0D9"/>
-            </a:solidFill>
-          </a:ln>
-          <a:effectLst/>
-        </p:spPr>
-        <p:style>
-          <a:lnRef idx="1">
-            <a:schemeClr val="accent1"/>
-          </a:lnRef>
-          <a:fillRef idx="3">
-            <a:schemeClr val="accent1"/>
-          </a:fillRef>
-          <a:effectRef idx="2">
-            <a:schemeClr val="accent1"/>
-          </a:effectRef>
-          <a:fontRef idx="minor">
-            <a:schemeClr val="lt1"/>
-          </a:fontRef>
-        </p:style>
-        <p:txBody>
-          <a:bodyPr rtlCol="0" anchor="ctr" wrap="square" lIns="164592" rIns="164592" tIns="128016" bIns="128016"/>
-          <a:lstStyle/>
-          <a:p>
-            <a:pPr algn="ctr">
-              <a:lnSpc>
-                <a:spcPct val="125000"/>
-              </a:lnSpc>
-            </a:pPr>
-            <a:r>
-              <a:rPr sz="1150">
-                <a:solidFill>
-                  <a:srgbClr val="898781"/>
-                </a:solidFill>
-                <a:latin typeface="Consolas"/>
-              </a:rPr>
-              <a:t>PythonParser.java</a:t>
+              <a:t>4. TypeScript 'await' was incorrectly treated as a modifier, collapsing awaited/non-awaited calls</a:t>
             </a:r>
           </a:p>
           <a:p>
             <a:pPr>
               <a:lnSpc>
-                <a:spcPct val="125000"/>
-              </a:lnSpc>
-            </a:pPr>
-            <a:r>
-              <a:rPr sz="1150">
-                <a:solidFill>
-                  <a:srgbClr val="006300"/>
-                </a:solidFill>
-                <a:latin typeface="Consolas"/>
-              </a:rPr>
-              <a:t>+ tokenizer.slashSlashComments(false);</a:t>
+                <a:spcPct val="115000"/>
+              </a:lnSpc>
+              <a:spcAft>
+                <a:spcPts val="1800"/>
+              </a:spcAft>
+            </a:pPr>
+            <a:r>
+              <a:rPr sz="1850" b="1">
+                <a:solidFill>
+                  <a:srgbClr val="1A1A18"/>
+                </a:solidFill>
+                <a:latin typeface="Calibri"/>
+              </a:rPr>
+              <a:t>5. Go raw string literals corrupted backslashes and lost embedded double-quotes</a:t>
             </a:r>
           </a:p>
           <a:p>
             <a:pPr>
               <a:lnSpc>
-                <a:spcPct val="125000"/>
-              </a:lnSpc>
-            </a:pPr>
-            <a:r>
-              <a:rPr sz="1150">
-                <a:solidFill>
-                  <a:srgbClr val="006300"/>
-                </a:solidFill>
-                <a:latin typeface="Consolas"/>
-              </a:rPr>
-              <a:t>+ tokenizer.ordinaryChar('/');  // '//' is floor-division, not a comment</a:t>
-            </a:r>
-          </a:p>
-        </p:txBody>
-      </p:sp>
-      <p:sp>
-        <p:nvSpPr>
-          <p:cNvPr id="15" name="Rectangle 14"/>
-          <p:cNvSpPr/>
-          <p:nvPr/>
-        </p:nvSpPr>
-        <p:spPr>
-          <a:xfrm>
-            <a:off x="6355080" y="3977639"/>
-            <a:ext cx="5257800" cy="2331720"/>
-          </a:xfrm>
-          <a:prstGeom prst="rect">
-            <a:avLst/>
-          </a:prstGeom>
-          <a:solidFill>
-            <a:srgbClr val="F7F6F2"/>
-          </a:solidFill>
-          <a:ln w="9525">
-            <a:solidFill>
-              <a:srgbClr val="E1E0D9"/>
-            </a:solidFill>
-          </a:ln>
-          <a:effectLst/>
-        </p:spPr>
-        <p:style>
-          <a:lnRef idx="1">
-            <a:schemeClr val="accent1"/>
-          </a:lnRef>
-          <a:fillRef idx="3">
-            <a:schemeClr val="accent1"/>
-          </a:fillRef>
-          <a:effectRef idx="2">
-            <a:schemeClr val="accent1"/>
-          </a:effectRef>
-          <a:fontRef idx="minor">
-            <a:schemeClr val="lt1"/>
-          </a:fontRef>
-        </p:style>
-        <p:txBody>
-          <a:bodyPr rtlCol="0" anchor="ctr"/>
-          <a:lstStyle/>
-          <a:p>
-            <a:pPr algn="ctr"/>
-          </a:p>
-        </p:txBody>
-      </p:sp>
-      <p:sp>
-        <p:nvSpPr>
-          <p:cNvPr id="16" name="TextBox 15"/>
-          <p:cNvSpPr txBox="1"/>
-          <p:nvPr/>
-        </p:nvSpPr>
-        <p:spPr>
-          <a:xfrm>
-            <a:off x="6537960" y="4087367"/>
-            <a:ext cx="4892040" cy="822960"/>
-          </a:xfrm>
-          <a:prstGeom prst="rect">
-            <a:avLst/>
-          </a:prstGeom>
-          <a:noFill/>
-        </p:spPr>
-        <p:txBody>
-          <a:bodyPr wrap="square">
-            <a:spAutoFit/>
-          </a:bodyPr>
-          <a:lstStyle/>
-          <a:p>
-            <a:r>
-              <a:rPr sz="1500" b="1">
+                <a:spcPct val="115000"/>
+              </a:lnSpc>
+              <a:spcAft>
+                <a:spcPts val="1800"/>
+              </a:spcAft>
+            </a:pPr>
+            <a:r>
+              <a:rPr sz="1850" b="1">
                 <a:solidFill>
                   <a:srgbClr val="1A1A18"/>
                 </a:solidFill>
                 <a:latin typeface="Calibri"/>
               </a:rPr>
-              <a:t>4.  TypeScript await treated as a modifier</a:t>
-            </a:r>
-          </a:p>
-          <a:p>
-            <a:r>
-              <a:rPr sz="1150" i="1">
-                <a:solidFill>
-                  <a:srgbClr val="52514E"/>
-                </a:solidFill>
-                <a:latin typeface="Calibri"/>
-              </a:rPr>
-              <a:t>Awaited and non-awaited calls fingerprinted identically</a:t>
-            </a:r>
-          </a:p>
-        </p:txBody>
-      </p:sp>
-      <p:sp>
-        <p:nvSpPr>
-          <p:cNvPr id="17" name="Rectangle 16"/>
-          <p:cNvSpPr/>
-          <p:nvPr/>
-        </p:nvSpPr>
-        <p:spPr>
-          <a:xfrm>
-            <a:off x="6537960" y="4937759"/>
-            <a:ext cx="4892040" cy="1234440"/>
-          </a:xfrm>
-          <a:prstGeom prst="rect">
-            <a:avLst/>
-          </a:prstGeom>
-          <a:solidFill>
-            <a:srgbClr val="222220"/>
-          </a:solidFill>
-          <a:ln w="9525">
-            <a:solidFill>
-              <a:srgbClr val="E1E0D9"/>
-            </a:solidFill>
-          </a:ln>
-          <a:effectLst/>
-        </p:spPr>
-        <p:style>
-          <a:lnRef idx="1">
-            <a:schemeClr val="accent1"/>
-          </a:lnRef>
-          <a:fillRef idx="3">
-            <a:schemeClr val="accent1"/>
-          </a:fillRef>
-          <a:effectRef idx="2">
-            <a:schemeClr val="accent1"/>
-          </a:effectRef>
-          <a:fontRef idx="minor">
-            <a:schemeClr val="lt1"/>
-          </a:fontRef>
-        </p:style>
-        <p:txBody>
-          <a:bodyPr rtlCol="0" anchor="ctr" wrap="square" lIns="164592" rIns="164592" tIns="128016" bIns="128016"/>
-          <a:lstStyle/>
-          <a:p>
-            <a:pPr algn="ctr">
-              <a:lnSpc>
-                <a:spcPct val="125000"/>
-              </a:lnSpc>
-            </a:pPr>
-            <a:r>
-              <a:rPr sz="1150">
-                <a:solidFill>
-                  <a:srgbClr val="898781"/>
-                </a:solidFill>
-                <a:latin typeface="Consolas"/>
-              </a:rPr>
-              <a:t>TypeScriptParserFactory.java</a:t>
+              <a:t>6. TypeScript/JavaScript contextual keywords (get, set, from, of, is, as, etc.) were misclassified as keyword declarations when used as ordinary names</a:t>
             </a:r>
           </a:p>
           <a:p>
             <a:pPr>
               <a:lnSpc>
-                <a:spcPct val="125000"/>
-              </a:lnSpc>
-            </a:pPr>
-            <a:r>
-              <a:rPr sz="1150">
-                <a:solidFill>
-                  <a:srgbClr val="898781"/>
-                </a:solidFill>
-                <a:latin typeface="Consolas"/>
-              </a:rPr>
-              <a:t>// 'await' intentionally absent from MODIFIERS: it's an expression</a:t>
-            </a:r>
-          </a:p>
-          <a:p>
-            <a:pPr>
-              <a:lnSpc>
-                <a:spcPct val="125000"/>
-              </a:lnSpc>
-            </a:pPr>
-            <a:r>
-              <a:rPr sz="1150">
-                <a:solidFill>
-                  <a:srgbClr val="898781"/>
-                </a:solidFill>
-                <a:latin typeface="Consolas"/>
-              </a:rPr>
-              <a:t>// operator; stripping it would lose real behavioural differences</a:t>
+                <a:spcPct val="115000"/>
+              </a:lnSpc>
+              <a:spcAft>
+                <a:spcPts val="1800"/>
+              </a:spcAft>
+            </a:pPr>
+            <a:r>
+              <a:rPr sz="1850" b="1">
+                <a:solidFill>
+                  <a:srgbClr val="1A1A18"/>
+                </a:solidFill>
+                <a:latin typeface="Calibri"/>
+              </a:rPr>
+              <a:t>7. get/set and other contextual keywords used as object-literal keys or parameters were incorrectly stripped by ignoreModifiers</a:t>
             </a:r>
           </a:p>
         </p:txBody>
@@ -7672,7 +7072,7 @@
                 </a:solidFill>
                 <a:latin typeface="Calibri"/>
               </a:rPr>
-              <a:t>■ Four bug fixes, explained</a:t>
+              <a:t>■ Seven bug fixes, explained</a:t>
             </a:r>
           </a:p>
           <a:p>
@@ -8094,7 +7494,7 @@
             </a:r>
           </a:p>
           <a:p>
-            <a:pPr>
+            <a:pPr lvl="1">
               <a:lnSpc>
                 <a:spcPct val="115000"/>
               </a:lnSpc>
@@ -8103,17 +7503,17 @@
               </a:spcAft>
             </a:pPr>
             <a:r>
-              <a:rPr sz="1700" b="1">
-                <a:solidFill>
-                  <a:srgbClr val="1A1A18"/>
-                </a:solidFill>
-                <a:latin typeface="Calibri"/>
-              </a:rPr>
-              <a:t>■ TypeScript: enhanced</a:t>
-            </a:r>
-          </a:p>
-          <a:p>
-            <a:pPr lvl="1">
+              <a:rPr sz="1500" b="0">
+                <a:solidFill>
+                  <a:srgbClr val="52514E"/>
+                </a:solidFill>
+                <a:latin typeface="Calibri"/>
+              </a:rPr>
+              <a:t>– Fixed: raw string literals no longer corrupt backslashes or lose embedded double-quotes</a:t>
+            </a:r>
+          </a:p>
+          <a:p>
+            <a:pPr>
               <a:lnSpc>
                 <a:spcPct val="115000"/>
               </a:lnSpc>
@@ -8122,13 +7522,13 @@
               </a:spcAft>
             </a:pPr>
             <a:r>
-              <a:rPr sz="1500" b="0">
-                <a:solidFill>
-                  <a:srgbClr val="52514E"/>
-                </a:solidFill>
-                <a:latin typeface="Calibri"/>
-              </a:rPr>
-              <a:t>– Tuple types fully suppressed under ignoreTypeAnnotations, including nested arrays</a:t>
+              <a:rPr sz="1700" b="1">
+                <a:solidFill>
+                  <a:srgbClr val="1A1A18"/>
+                </a:solidFill>
+                <a:latin typeface="Calibri"/>
+              </a:rPr>
+              <a:t>■ TypeScript: enhanced</a:t>
             </a:r>
           </a:p>
           <a:p>
@@ -8147,7 +7547,26 @@
                 </a:solidFill>
                 <a:latin typeface="Calibri"/>
               </a:rPr>
-              <a:t>– Two classification bugs fixed (await, single-letter generics)</a:t>
+              <a:t>– Tuple types fully suppressed under ignoreTypeAnnotations, including nested arrays</a:t>
+            </a:r>
+          </a:p>
+          <a:p>
+            <a:pPr lvl="1">
+              <a:lnSpc>
+                <a:spcPct val="115000"/>
+              </a:lnSpc>
+              <a:spcAft>
+                <a:spcPts val="800"/>
+              </a:spcAft>
+            </a:pPr>
+            <a:r>
+              <a:rPr sz="1500" b="0">
+                <a:solidFill>
+                  <a:srgbClr val="52514E"/>
+                </a:solidFill>
+                <a:latin typeface="Calibri"/>
+              </a:rPr>
+              <a:t>– Four classification bugs fixed (await, single-letter generics, contextual keywords, object-literal keys)</a:t>
             </a:r>
           </a:p>
           <a:p>
@@ -8748,7 +8167,7 @@
                 </a:solidFill>
                 <a:latin typeface="Calibri"/>
               </a:rPr>
-              <a:t>Go support added, current HEAD</a:t>
+              <a:t>Go support added; PRs #24–#26 later merged to main</a:t>
             </a:r>
           </a:p>
         </p:txBody>
@@ -9682,6 +9101,25 @@
               <a:t>■ New: “go” accepted as a value for -language and -defaultLanguage</a:t>
             </a:r>
           </a:p>
+          <a:p>
+            <a:pPr>
+              <a:lnSpc>
+                <a:spcPct val="115000"/>
+              </a:lnSpc>
+              <a:spcAft>
+                <a:spcPts val="700"/>
+              </a:spcAft>
+            </a:pPr>
+            <a:r>
+              <a:rPr sz="1550" b="1">
+                <a:solidFill>
+                  <a:srgbClr val="1A1A18"/>
+                </a:solidFill>
+                <a:latin typeface="Calibri"/>
+              </a:rPr>
+              <a:t>■ Fixed: raw string literals no longer corrupt backslashes or lose embedded double-quotes</a:t>
+            </a:r>
+          </a:p>
         </p:txBody>
       </p:sp>
       <p:sp>
@@ -10663,6 +10101,44 @@
                 <a:latin typeface="Calibri"/>
               </a:rPr>
               <a:t>– await is an expression operator; stripping it made awaited and non-awaited calls fingerprint identically</a:t>
+            </a:r>
+          </a:p>
+          <a:p>
+            <a:pPr>
+              <a:lnSpc>
+                <a:spcPct val="115000"/>
+              </a:lnSpc>
+              <a:spcAft>
+                <a:spcPts val="1200"/>
+              </a:spcAft>
+            </a:pPr>
+            <a:r>
+              <a:rPr sz="1750" b="1">
+                <a:solidFill>
+                  <a:srgbClr val="1A1A18"/>
+                </a:solidFill>
+                <a:latin typeface="Calibri"/>
+              </a:rPr>
+              <a:t>■ Fixed: contextual keywords (get, set, from, of, is, as, declare, namespace, module, abstract, override, readonly, out, satisfies) used as ordinary names no longer misclassified as keyword declarations</a:t>
+            </a:r>
+          </a:p>
+          <a:p>
+            <a:pPr>
+              <a:lnSpc>
+                <a:spcPct val="115000"/>
+              </a:lnSpc>
+              <a:spcAft>
+                <a:spcPts val="1200"/>
+              </a:spcAft>
+            </a:pPr>
+            <a:r>
+              <a:rPr sz="1750" b="1">
+                <a:solidFill>
+                  <a:srgbClr val="1A1A18"/>
+                </a:solidFill>
+                <a:latin typeface="Calibri"/>
+              </a:rPr>
+              <a:t>■ Fixed: get/set and other contextual keywords used as object-literal keys or parameter names no longer stripped by ignoreModifiers</a:t>
             </a:r>
           </a:p>
           <a:p>

</xml_diff>